<commit_message>
System Design 101 (vi): label the sd-08-020 unit counts as explicit declarations, require independent failures in sd-08-016
Co-Authored-By: Claude Sonnet 5.5 <noreply@anthropic.com>
Claude-Session: https://claude.ai/code/session_01DkN7YTqFfdjb8A8J5ehSWS
</commit_message>
<xml_diff>
--- a/system-design-101/vi/lessons/sd-08-020/slides/sd-08-020.pptx
+++ b/system-design-101/vi/lessons/sd-08-020/slides/sd-08-020.pptx
@@ -7133,6 +7133,61 @@
               <a:buNone/>
             </a:pPr>
             <a:r>
+              <a:rPr lang="en-US" sz="2400" b="1" dirty="0" spc="-8" kern="0">
+                <a:solidFill>
+                  <a:srgbClr val="14161C"/>
+                </a:solidFill>
+                <a:latin typeface="Be Vietnam Pro" pitchFamily="34" charset="0"/>
+                <a:ea typeface="Be Vietnam Pro" pitchFamily="34" charset="-122"/>
+                <a:cs typeface="Be Vietnam Pro" pitchFamily="34" charset="-120"/>
+              </a:rPr>
+              <a:t>Theo</a:t>
+            </a:r>
+            <a:r>
+              <a:rPr lang="en-US" sz="2400" b="1" dirty="0" spc="-2" kern="0">
+                <a:solidFill>
+                  <a:srgbClr val="14161C"/>
+                </a:solidFill>
+                <a:latin typeface="Be Vietnam Pro" pitchFamily="34" charset="0"/>
+                <a:ea typeface="Be Vietnam Pro" pitchFamily="34" charset="-122"/>
+                <a:cs typeface="Be Vietnam Pro" pitchFamily="34" charset="-120"/>
+              </a:rPr>
+              <a:t> khai</a:t>
+            </a:r>
+            <a:r>
+              <a:rPr lang="en-US" sz="2400" b="1" dirty="0" spc="4" kern="0">
+                <a:solidFill>
+                  <a:srgbClr val="14161C"/>
+                </a:solidFill>
+                <a:latin typeface="Be Vietnam Pro" pitchFamily="34" charset="0"/>
+                <a:ea typeface="Be Vietnam Pro" pitchFamily="34" charset="-122"/>
+                <a:cs typeface="Be Vietnam Pro" pitchFamily="34" charset="-120"/>
+              </a:rPr>
+              <a:t> báo</a:t>
+            </a:r>
+            <a:r>
+              <a:rPr lang="en-US" sz="2400" b="1" dirty="0" spc="5" kern="0">
+                <a:solidFill>
+                  <a:srgbClr val="14161C"/>
+                </a:solidFill>
+                <a:latin typeface="Be Vietnam Pro" pitchFamily="34" charset="0"/>
+                <a:ea typeface="Be Vietnam Pro" pitchFamily="34" charset="-122"/>
+                <a:cs typeface="Be Vietnam Pro" pitchFamily="34" charset="-120"/>
+              </a:rPr>
+              <a:t> tường</a:t>
+            </a:r>
+            <a:r>
+              <a:rPr lang="en-US" sz="2400" b="1" dirty="0" spc="0" kern="0">
+                <a:solidFill>
+                  <a:srgbClr val="14161C"/>
+                </a:solidFill>
+                <a:latin typeface="Be Vietnam Pro" pitchFamily="34" charset="0"/>
+                <a:ea typeface="Be Vietnam Pro" pitchFamily="34" charset="-122"/>
+                <a:cs typeface="Be Vietnam Pro" pitchFamily="34" charset="-120"/>
+              </a:rPr>
+              <a:t> minh: chuỗi</a:t>
+            </a:r>
+            <a:r>
               <a:rPr lang="en-US" sz="2400" b="1" dirty="0" spc="-1" kern="0">
                 <a:solidFill>
                   <a:srgbClr val="14161C"/>
@@ -7141,54 +7196,21 @@
                 <a:ea typeface="Be Vietnam Pro" pitchFamily="34" charset="-122"/>
                 <a:cs typeface="Be Vietnam Pro" pitchFamily="34" charset="-120"/>
               </a:rPr>
-              <a:t>Chuỗi</a:t>
-            </a:r>
-            <a:r>
-              <a:rPr lang="en-US" sz="2400" b="1" dirty="0" spc="1" kern="0">
-                <a:solidFill>
-                  <a:srgbClr val="14161C"/>
-                </a:solidFill>
-                <a:latin typeface="Be Vietnam Pro" pitchFamily="34" charset="0"/>
-                <a:ea typeface="Be Vietnam Pro" pitchFamily="34" charset="-122"/>
-                <a:cs typeface="Be Vietnam Pro" pitchFamily="34" charset="-120"/>
-              </a:rPr>
-              <a:t> thứ</a:t>
-            </a:r>
-            <a:r>
-              <a:rPr lang="en-US" sz="2400" b="1" dirty="0" spc="3" kern="0">
-                <a:solidFill>
-                  <a:srgbClr val="14161C"/>
-                </a:solidFill>
-                <a:latin typeface="Be Vietnam Pro" pitchFamily="34" charset="0"/>
-                <a:ea typeface="Be Vietnam Pro" pitchFamily="34" charset="-122"/>
-                <a:cs typeface="Be Vietnam Pro" pitchFamily="34" charset="-120"/>
-              </a:rPr>
-              <a:t> tự</a:t>
-            </a:r>
-            <a:r>
-              <a:rPr lang="en-US" sz="2400" b="1" dirty="0" spc="0" kern="0">
-                <a:solidFill>
-                  <a:srgbClr val="14161C"/>
-                </a:solidFill>
-                <a:latin typeface="Be Vietnam Pro" pitchFamily="34" charset="0"/>
-                <a:ea typeface="Be Vietnam Pro" pitchFamily="34" charset="-122"/>
-                <a:cs typeface="Be Vietnam Pro" pitchFamily="34" charset="-120"/>
-              </a:rPr>
               <a:t> dài</a:t>
             </a:r>
             <a:r>
-              <a:rPr lang="en-US" sz="2400" b="1" dirty="0" spc="-5" kern="0">
-                <a:solidFill>
-                  <a:srgbClr val="14161C"/>
-                </a:solidFill>
-                <a:latin typeface="Be Vietnam Pro" pitchFamily="34" charset="0"/>
-                <a:ea typeface="Be Vietnam Pro" pitchFamily="34" charset="-122"/>
-                <a:cs typeface="Be Vietnam Pro" pitchFamily="34" charset="-120"/>
-              </a:rPr>
-              <a:t> nhất:</a:t>
-            </a:r>
-            <a:r>
-              <a:rPr lang="en-US" sz="2400" b="1" dirty="0" spc="0" kern="0">
+              <a:rPr lang="en-US" sz="2400" b="1" dirty="0" spc="-6" kern="0">
+                <a:solidFill>
+                  <a:srgbClr val="14161C"/>
+                </a:solidFill>
+                <a:latin typeface="Be Vietnam Pro" pitchFamily="34" charset="0"/>
+                <a:ea typeface="Be Vietnam Pro" pitchFamily="34" charset="-122"/>
+                <a:cs typeface="Be Vietnam Pro" pitchFamily="34" charset="-120"/>
+              </a:rPr>
+              <a:t> nhất</a:t>
+            </a:r>
+            <a:r>
+              <a:rPr lang="en-US" sz="2400" b="1" dirty="0" spc="-1" kern="0">
                 <a:solidFill>
                   <a:srgbClr val="14161C"/>
                 </a:solidFill>
@@ -7323,15 +7345,26 @@
               <a:t> không</a:t>
             </a:r>
             <a:r>
-              <a:rPr lang="en-US" sz="2400" b="1" dirty="0" spc="-4" kern="0">
-                <a:solidFill>
-                  <a:srgbClr val="14161C"/>
-                </a:solidFill>
-                <a:latin typeface="Be Vietnam Pro" pitchFamily="34" charset="0"/>
-                <a:ea typeface="Be Vietnam Pro" pitchFamily="34" charset="-122"/>
-                <a:cs typeface="Be Vietnam Pro" pitchFamily="34" charset="-120"/>
-              </a:rPr>
-              <a:t> phải</a:t>
+              <a:rPr lang="en-US" sz="2400" b="1" dirty="0" spc="-1" kern="0">
+                <a:solidFill>
+                  <a:srgbClr val="14161C"/>
+                </a:solidFill>
+                <a:latin typeface="Be Vietnam Pro" pitchFamily="34" charset="0"/>
+                <a:ea typeface="Be Vietnam Pro" pitchFamily="34" charset="-122"/>
+                <a:cs typeface="Be Vietnam Pro" pitchFamily="34" charset="-120"/>
+              </a:rPr>
+              <a:t> khai</a:t>
+            </a:r>
+            <a:r>
+              <a:rPr lang="en-US" sz="2400" b="1" dirty="0" spc="3" kern="0">
+                <a:solidFill>
+                  <a:srgbClr val="14161C"/>
+                </a:solidFill>
+                <a:latin typeface="Be Vietnam Pro" pitchFamily="34" charset="0"/>
+                <a:ea typeface="Be Vietnam Pro" pitchFamily="34" charset="-122"/>
+                <a:cs typeface="Be Vietnam Pro" pitchFamily="34" charset="-120"/>
+              </a:rPr>
+              <a:t> báo</a:t>
             </a:r>
             <a:r>
               <a:rPr lang="en-US" sz="2400" b="1" dirty="0" spc="-3" kern="0">
@@ -7345,37 +7378,81 @@
               <a:t> chờ</a:t>
             </a:r>
             <a:r>
-              <a:rPr lang="en-US" sz="2400" b="1" dirty="0" spc="7" kern="0">
-                <a:solidFill>
-                  <a:srgbClr val="14161C"/>
-                </a:solidFill>
-                <a:latin typeface="Be Vietnam Pro" pitchFamily="34" charset="0"/>
-                <a:ea typeface="Be Vietnam Pro" pitchFamily="34" charset="-122"/>
-                <a:cs typeface="Be Vietnam Pro" pitchFamily="34" charset="-120"/>
-              </a:rPr>
-              <a:t> đơn</a:t>
-            </a:r>
-            <a:r>
-              <a:rPr lang="en-US" sz="2400" b="1" dirty="0" spc="1" kern="0">
-                <a:solidFill>
-                  <a:srgbClr val="14161C"/>
-                </a:solidFill>
-                <a:latin typeface="Be Vietnam Pro" pitchFamily="34" charset="0"/>
-                <a:ea typeface="Be Vietnam Pro" pitchFamily="34" charset="-122"/>
-                <a:cs typeface="Be Vietnam Pro" pitchFamily="34" charset="-120"/>
-              </a:rPr>
-              <a:t> vị</a:t>
-            </a:r>
-            <a:r>
-              <a:rPr lang="en-US" sz="2400" b="1" dirty="0" spc="2" kern="0">
-                <a:solidFill>
-                  <a:srgbClr val="14161C"/>
-                </a:solidFill>
-                <a:latin typeface="Be Vietnam Pro" pitchFamily="34" charset="0"/>
-                <a:ea typeface="Be Vietnam Pro" pitchFamily="34" charset="-122"/>
-                <a:cs typeface="Be Vietnam Pro" pitchFamily="34" charset="-120"/>
-              </a:rPr>
-              <a:t> nào</a:t>
+              <a:rPr lang="en-US" sz="2400" b="1" dirty="0" spc="4" kern="0">
+                <a:solidFill>
+                  <a:srgbClr val="14161C"/>
+                </a:solidFill>
+                <a:latin typeface="Be Vietnam Pro" pitchFamily="34" charset="0"/>
+                <a:ea typeface="Be Vietnam Pro" pitchFamily="34" charset="-122"/>
+                <a:cs typeface="Be Vietnam Pro" pitchFamily="34" charset="-120"/>
+              </a:rPr>
+              <a:t> ai</a:t>
+            </a:r>
+            <a:r>
+              <a:rPr lang="en-US" sz="2400" b="1" dirty="0" spc="-23" kern="0">
+                <a:solidFill>
+                  <a:srgbClr val="14161C"/>
+                </a:solidFill>
+                <a:latin typeface="Be Vietnam Pro" pitchFamily="34" charset="0"/>
+                <a:ea typeface="Be Vietnam Pro" pitchFamily="34" charset="-122"/>
+                <a:cs typeface="Be Vietnam Pro" pitchFamily="34" charset="-120"/>
+              </a:rPr>
+              <a:t> (systemd</a:t>
+            </a:r>
+            <a:r>
+              <a:rPr lang="en-US" sz="2400" b="1" dirty="0" spc="-6" kern="0">
+                <a:solidFill>
+                  <a:srgbClr val="14161C"/>
+                </a:solidFill>
+                <a:latin typeface="Be Vietnam Pro" pitchFamily="34" charset="0"/>
+                <a:ea typeface="Be Vietnam Pro" pitchFamily="34" charset="-122"/>
+                <a:cs typeface="Be Vietnam Pro" pitchFamily="34" charset="-120"/>
+              </a:rPr>
+              <a:t> còn</a:t>
+            </a:r>
+            <a:r>
+              <a:rPr lang="en-US" sz="2400" b="1" dirty="0" spc="3" kern="0">
+                <a:solidFill>
+                  <a:srgbClr val="14161C"/>
+                </a:solidFill>
+                <a:latin typeface="Be Vietnam Pro" pitchFamily="34" charset="0"/>
+                <a:ea typeface="Be Vietnam Pro" pitchFamily="34" charset="-122"/>
+                <a:cs typeface="Be Vietnam Pro" pitchFamily="34" charset="-120"/>
+              </a:rPr>
+              <a:t> tự</a:t>
+            </a:r>
+            <a:r>
+              <a:rPr lang="en-US" sz="2400" b="1" dirty="0" spc="-7" kern="0">
+                <a:solidFill>
+                  <a:srgbClr val="14161C"/>
+                </a:solidFill>
+                <a:latin typeface="Be Vietnam Pro" pitchFamily="34" charset="0"/>
+                <a:ea typeface="Be Vietnam Pro" pitchFamily="34" charset="-122"/>
+                <a:cs typeface="Be Vietnam Pro" pitchFamily="34" charset="-120"/>
+              </a:rPr>
+              <a:t> thêm</a:t>
+            </a:r>
+            <a:r>
+              <a:rPr lang="en-US" sz="2400" b="1" dirty="0" spc="-11" kern="0">
+                <a:solidFill>
+                  <a:srgbClr val="14161C"/>
+                </a:solidFill>
+                <a:latin typeface="Be Vietnam Pro" pitchFamily="34" charset="0"/>
+                <a:ea typeface="Be Vietnam Pro" pitchFamily="34" charset="-122"/>
+                <a:cs typeface="Be Vietnam Pro" pitchFamily="34" charset="-120"/>
+              </a:rPr>
+              <a:t> ràng</a:t>
+            </a:r>
+            <a:r>
+              <a:rPr lang="en-US" sz="2400" b="1" dirty="0" spc="-1" kern="0">
+                <a:solidFill>
+                  <a:srgbClr val="14161C"/>
+                </a:solidFill>
+                <a:latin typeface="Be Vietnam Pro" pitchFamily="34" charset="0"/>
+                <a:ea typeface="Be Vietnam Pro" pitchFamily="34" charset="-122"/>
+                <a:cs typeface="Be Vietnam Pro" pitchFamily="34" charset="-120"/>
+              </a:rPr>
+              <a:t> buộc)</a:t>
             </a:r>
             <a:endParaRPr lang="en-US" sz="2400" dirty="0"/>
           </a:p>

</xml_diff>